<commit_message>
feat: add Team Velocity and Stakeholder Sentiment as 5th and 6th health indicators
- New src/detr/sentiment.py: AI-powered NLP sentiment analysis via Gemini
- New src/detr/velocity.py: Task throughput scoring with team size adjustment
- Updated weights: schedule 20%, budget 20%, milestone 15%, blockers 20%, sentiment 15%, velocity 10%
- Updated all sample data files with stakeholderFeedback and velocity fields
- Updated RAG_Methodology.md to document all 6 indicators
- Fixed JSON parser in generate_presentation.py for robustness
- Regenerated all batch outputs and monthly presentation
</commit_message>
<xml_diff>
--- a/outputs/Monthly_Executive_Report.pptx
+++ b/outputs/Monthly_Executive_Report.pptx
@@ -3143,7 +3143,7 @@
               </a:defRPr>
             </a:pPr>
             <a:r>
-              <a:t>Portfolio Delivery Status &amp; Strategic Alignment</a:t>
+              <a:t>Delivery Performance Analysis and Strategic Outlook</a:t>
             </a:r>
           </a:p>
         </p:txBody>
@@ -3208,7 +3208,7 @@
               </a:defRPr>
             </a:pPr>
             <a:r>
-              <a:t>Current status across active projects</a:t>
+              <a:t>Status Distribution and Delivery Confidence</a:t>
             </a:r>
           </a:p>
         </p:txBody>
@@ -3246,7 +3246,7 @@
               </a:defRPr>
             </a:pPr>
             <a:r>
-              <a:t>• Project Alpha (GREEN): Performing to plan; final phase execution</a:t>
+              <a:t>• Portfolio Distribution: 1 Green (Project Alpha), 1 Amber (Project Beta), 1 Red (Project Gamma)</a:t>
             </a:r>
           </a:p>
           <a:p>
@@ -3261,7 +3261,7 @@
               </a:defRPr>
             </a:pPr>
             <a:r>
-              <a:t>• Project Beta (AMBER): Schedule variance and technical dependencies impacting completion</a:t>
+              <a:t>• Project Alpha: Demonstrating optimal performance across all metrics with 100% confidence</a:t>
             </a:r>
           </a:p>
           <a:p>
@@ -3276,7 +3276,7 @@
               </a:defRPr>
             </a:pPr>
             <a:r>
-              <a:t>• Project Gamma (RED): Significant schedule and budget deviation; critical intervention required</a:t>
+              <a:t>• Project Beta: At-risk status due to schedule slippage; budget remains healthy but sentiment is deteriorating</a:t>
             </a:r>
           </a:p>
           <a:p>
@@ -3291,7 +3291,7 @@
               </a:defRPr>
             </a:pPr>
             <a:r>
-              <a:t>• Portfolio Confidence: High overall data confidence, highlighting clear visibility into performance gaps</a:t>
+              <a:t>• Project Gamma: Critical status; significant schedule and budget variances coupled with low stakeholder trust</a:t>
             </a:r>
           </a:p>
         </p:txBody>
@@ -3356,7 +3356,7 @@
               </a:defRPr>
             </a:pPr>
             <a:r>
-              <a:t>Synthesis of project delivery patterns</a:t>
+              <a:t>Performance Patterns Across the Portfolio</a:t>
             </a:r>
           </a:p>
         </p:txBody>
@@ -3394,7 +3394,7 @@
               </a:defRPr>
             </a:pPr>
             <a:r>
-              <a:t>• Budget Efficiency: Strong financial management observed in Alpha and Beta</a:t>
+              <a:t>• Divergence in Maturity: High performance correlates with stable scope and clear team communication</a:t>
             </a:r>
           </a:p>
           <a:p>
@@ -3409,7 +3409,7 @@
               </a:defRPr>
             </a:pPr>
             <a:r>
-              <a:t>• Schedule Drift: Widespread trend of exceeding planned durations (all projects currently at or over timeline)</a:t>
+              <a:t>• Budget vs. Schedule: Projects with scope instability (Gamma) and external dependencies (Beta) are consuming buffers rapidly</a:t>
             </a:r>
           </a:p>
           <a:p>
@@ -3424,7 +3424,7 @@
               </a:defRPr>
             </a:pPr>
             <a:r>
-              <a:t>• Velocity Mismatch: Milestone completion rates are not tracking linearly with duration increases</a:t>
+              <a:t>• Sentiment Degradation: Stakeholder trust is tied directly to communication transparency rather than just budget spend</a:t>
             </a:r>
           </a:p>
           <a:p>
@@ -3439,7 +3439,7 @@
               </a:defRPr>
             </a:pPr>
             <a:r>
-              <a:t>• Dependency Friction: External technical dependencies and client resource availability are the primary drivers of stall points</a:t>
+              <a:t>• Efficiency Gap: A 33% variance in task completion rates suggests inconsistent execution standards across project teams</a:t>
             </a:r>
           </a:p>
         </p:txBody>
@@ -3504,7 +3504,7 @@
               </a:defRPr>
             </a:pPr>
             <a:r>
-              <a:t>Systemic challenges facing the portfolio</a:t>
+              <a:t>Systemic Impediments to Success</a:t>
             </a:r>
           </a:p>
         </p:txBody>
@@ -3542,7 +3542,7 @@
               </a:defRPr>
             </a:pPr>
             <a:r>
-              <a:t>• Primary Risks:</a:t>
+              <a:t>• External Dependencies: API integration delays (Beta) creating critical path bottlenecks</a:t>
             </a:r>
           </a:p>
           <a:p>
@@ -3557,7 +3557,7 @@
               </a:defRPr>
             </a:pPr>
             <a:r>
-              <a:t>• Client resource unavailability (Gamma) causing total project stall</a:t>
+              <a:t>• Resource Availability: Persistent unavailability of client resources stalling progress in Gamma</a:t>
             </a:r>
           </a:p>
           <a:p>
@@ -3572,22 +3572,7 @@
               </a:defRPr>
             </a:pPr>
             <a:r>
-              <a:t>• Scope creep (Gamma) invalidating existing financial and schedule baselines</a:t>
-            </a:r>
-          </a:p>
-          <a:p>
-            <a:pPr>
-              <a:spcAft>
-                <a:spcPts val="1000"/>
-              </a:spcAft>
-              <a:defRPr sz="1400">
-                <a:solidFill>
-                  <a:srgbClr val="212529"/>
-                </a:solidFill>
-              </a:defRPr>
-            </a:pPr>
-            <a:r>
-              <a:t>• Technical dependencies (Beta) creating integration blockers</a:t>
+              <a:t>• Scope Management: Uncontrolled scope creep within Module B (Gamma) exacerbating budget overruns</a:t>
             </a:r>
           </a:p>
         </p:txBody>
@@ -3625,7 +3610,7 @@
               </a:defRPr>
             </a:pPr>
             <a:r>
-              <a:t>• Systemic Bottlenecks:</a:t>
+              <a:t>• Vendor Management: Current vendor performance is a primary driver of stakeholder frustration in Beta</a:t>
             </a:r>
           </a:p>
           <a:p>
@@ -3640,37 +3625,7 @@
               </a:defRPr>
             </a:pPr>
             <a:r>
-              <a:t>• Lack of internal capacity for critical path tasks</a:t>
-            </a:r>
-          </a:p>
-          <a:p>
-            <a:pPr>
-              <a:spcAft>
-                <a:spcPts val="1000"/>
-              </a:spcAft>
-              <a:defRPr sz="1400">
-                <a:solidFill>
-                  <a:srgbClr val="212529"/>
-                </a:solidFill>
-              </a:defRPr>
-            </a:pPr>
-            <a:r>
-              <a:t>• Inadequate change control implementation for scope changes</a:t>
-            </a:r>
-          </a:p>
-          <a:p>
-            <a:pPr>
-              <a:spcAft>
-                <a:spcPts val="1000"/>
-              </a:spcAft>
-              <a:defRPr sz="1400">
-                <a:solidFill>
-                  <a:srgbClr val="212529"/>
-                </a:solidFill>
-              </a:defRPr>
-            </a:pPr>
-            <a:r>
-              <a:t>• External reliance on third-party API availability</a:t>
+              <a:t>• Communication Gaps: Lack of proactive reporting is transforming operational blockers into critical trust issues</a:t>
             </a:r>
           </a:p>
         </p:txBody>
@@ -3735,7 +3690,7 @@
               </a:defRPr>
             </a:pPr>
             <a:r>
-              <a:t>Leveraging portfolio liquidity to drive stabilization</a:t>
+              <a:t>Reallocation and Efficiency Strategies</a:t>
             </a:r>
           </a:p>
         </p:txBody>
@@ -3773,7 +3728,7 @@
               </a:defRPr>
             </a:pPr>
             <a:r>
-              <a:t>• Redeploy Alpha surplus: Utilize remaining project budget to support accelerated recovery in Beta/Gamma</a:t>
+              <a:t>• Fiscal Balancing: Leverage the $20k underspend from Project Alpha to support mitigation efforts in Red/Amber projects</a:t>
             </a:r>
           </a:p>
           <a:p>
@@ -3788,7 +3743,7 @@
               </a:defRPr>
             </a:pPr>
             <a:r>
-              <a:t>• Resource Load Balancing: Assess cross-project resource utilization to prioritize critical path tasks in Gamma</a:t>
+              <a:t>• Capacity Rebalancing: Audit team utilization on Beta/Gamma to ensure critical path tasks are prioritized over non-essential features</a:t>
             </a:r>
           </a:p>
           <a:p>
@@ -3803,7 +3758,7 @@
               </a:defRPr>
             </a:pPr>
             <a:r>
-              <a:t>• Financial Realignment: Initiate formal budget amendments for projects with high-severity scope creep</a:t>
+              <a:t>• Operational Transition: Initiate formal handovers for Project Alpha to free up project leadership bandwidth for recovery efforts</a:t>
             </a:r>
           </a:p>
           <a:p>
@@ -3818,7 +3773,7 @@
               </a:defRPr>
             </a:pPr>
             <a:r>
-              <a:t>• Resource Commitment: Secure mandatory client resource availability to clear high-severity blockers</a:t>
+              <a:t>• Vendor Accountability: Apply financial leverage from current vendor contracts to enforce delivery commitments for the API dependency</a:t>
             </a:r>
           </a:p>
         </p:txBody>
@@ -3883,7 +3838,7 @@
               </a:defRPr>
             </a:pPr>
             <a:r>
-              <a:t>Actionable roadmap for delivery stabilization</a:t>
+              <a:t>Roadmap for Portfolio Stabilization</a:t>
             </a:r>
           </a:p>
         </p:txBody>
@@ -3921,7 +3876,7 @@
               </a:defRPr>
             </a:pPr>
             <a:r>
-              <a:t>• Immediate Leadership Intervention: Schedule emergency review for Gamma to address resource blockers and scope</a:t>
+              <a:t>• Emergency Alignment: Conduct leadership-level syncs to reset scope and delivery expectations for Project Gamma</a:t>
             </a:r>
           </a:p>
           <a:p>
@@ -3936,7 +3891,7 @@
               </a:defRPr>
             </a:pPr>
             <a:r>
-              <a:t>• Change Control Board: Formally re-baseline project plans for Beta and Gamma to reflect reality</a:t>
+              <a:t>• Recovery Planning: Implement rigorous change control (Scope Freeze) for Gamma and finalize a re-baselined plan for Beta</a:t>
             </a:r>
           </a:p>
           <a:p>
@@ -3951,7 +3906,7 @@
               </a:defRPr>
             </a:pPr>
             <a:r>
-              <a:t>• Operational Transition: Finalize Alpha handover to ensure project closure remains on schedule</a:t>
+              <a:t>• Governance Enhancement: Standardize reporting cadence to improve stakeholder transparency and restore confidence</a:t>
             </a:r>
           </a:p>
           <a:p>
@@ -3966,7 +3921,7 @@
               </a:defRPr>
             </a:pPr>
             <a:r>
-              <a:t>• Proactive Monitoring: Implement weekly dependency reviews to identify and mitigate API/Client bottlenecks before they impact milestones</a:t>
+              <a:t>• Delivery Excellence: Formalize lessons learned from Project Alpha to replicate successful communication and execution models</a:t>
             </a:r>
           </a:p>
         </p:txBody>

</xml_diff>

<commit_message>
docs: update Loom video script with terminal PPTX reader instructions
</commit_message>
<xml_diff>
--- a/outputs/Monthly_Executive_Report.pptx
+++ b/outputs/Monthly_Executive_Report.pptx
@@ -3143,7 +3143,7 @@
               </a:defRPr>
             </a:pPr>
             <a:r>
-              <a:t>Delivery Performance Analysis and Strategic Outlook</a:t>
+              <a:t>Q3 Delivery Performance &amp; Strategic Alignment</a:t>
             </a:r>
           </a:p>
         </p:txBody>
@@ -3208,7 +3208,7 @@
               </a:defRPr>
             </a:pPr>
             <a:r>
-              <a:t>Status Distribution and Delivery Confidence</a:t>
+              <a:t>Aggregated Portfolio Performance Metrics</a:t>
             </a:r>
           </a:p>
         </p:txBody>
@@ -3246,7 +3246,7 @@
               </a:defRPr>
             </a:pPr>
             <a:r>
-              <a:t>• Portfolio Distribution: 1 Green (Project Alpha), 1 Amber (Project Beta), 1 Red (Project Gamma)</a:t>
+              <a:t>• Portfolio Distribution: 1 Green (Alpha), 1 Amber (Beta), 1 Red (Gamma)</a:t>
             </a:r>
           </a:p>
           <a:p>
@@ -3261,7 +3261,7 @@
               </a:defRPr>
             </a:pPr>
             <a:r>
-              <a:t>• Project Alpha: Demonstrating optimal performance across all metrics with 100% confidence</a:t>
+              <a:t>• Overall Delivery Confidence: High (100% data visibility across all workstreams)</a:t>
             </a:r>
           </a:p>
           <a:p>
@@ -3276,7 +3276,7 @@
               </a:defRPr>
             </a:pPr>
             <a:r>
-              <a:t>• Project Beta: At-risk status due to schedule slippage; budget remains healthy but sentiment is deteriorating</a:t>
+              <a:t>• Financial Health: Mixed performance with significant variances in schedule vs. budget tracking</a:t>
             </a:r>
           </a:p>
           <a:p>
@@ -3291,7 +3291,7 @@
               </a:defRPr>
             </a:pPr>
             <a:r>
-              <a:t>• Project Gamma: Critical status; significant schedule and budget variances coupled with low stakeholder trust</a:t>
+              <a:t>• Critical Path Alert: 66% of the portfolio requires active intervention to meet original exit criteria</a:t>
             </a:r>
           </a:p>
         </p:txBody>
@@ -3356,7 +3356,7 @@
               </a:defRPr>
             </a:pPr>
             <a:r>
-              <a:t>Performance Patterns Across the Portfolio</a:t>
+              <a:t>Portfolio Performance Patterns</a:t>
             </a:r>
           </a:p>
         </p:txBody>
@@ -3370,7 +3370,7 @@
         <p:spPr>
           <a:xfrm>
             <a:off x="457200" y="1371600"/>
-            <a:ext cx="8229600" cy="4572000"/>
+            <a:ext cx="3931920" cy="4572000"/>
           </a:xfrm>
           <a:prstGeom prst="rect">
             <a:avLst/>
@@ -3385,61 +3385,99 @@
           <a:p>
             <a:pPr>
               <a:spcAft>
-                <a:spcPts val="1400"/>
+                <a:spcPts val="1000"/>
               </a:spcAft>
-              <a:defRPr sz="1600">
+              <a:defRPr sz="1400">
                 <a:solidFill>
                   <a:srgbClr val="212529"/>
                 </a:solidFill>
               </a:defRPr>
             </a:pPr>
             <a:r>
-              <a:t>• Divergence in Maturity: High performance correlates with stable scope and clear team communication</a:t>
+              <a:t>• Positive: Budget discipline in stable projects like Alpha confirms strong baseline estimation</a:t>
             </a:r>
           </a:p>
           <a:p>
             <a:pPr>
               <a:spcAft>
-                <a:spcPts val="1400"/>
+                <a:spcPts val="1000"/>
               </a:spcAft>
-              <a:defRPr sz="1600">
+              <a:defRPr sz="1400">
                 <a:solidFill>
                   <a:srgbClr val="212529"/>
                 </a:solidFill>
               </a:defRPr>
             </a:pPr>
             <a:r>
-              <a:t>• Budget vs. Schedule: Projects with scope instability (Gamma) and external dependencies (Beta) are consuming buffers rapidly</a:t>
+              <a:t>• Negative: Schedule slippage is the primary indicator of portfolio instability</a:t>
             </a:r>
           </a:p>
           <a:p>
             <a:pPr>
               <a:spcAft>
-                <a:spcPts val="1400"/>
+                <a:spcPts val="1000"/>
               </a:spcAft>
-              <a:defRPr sz="1600">
+              <a:defRPr sz="1400">
                 <a:solidFill>
                   <a:srgbClr val="212529"/>
                 </a:solidFill>
               </a:defRPr>
             </a:pPr>
             <a:r>
-              <a:t>• Sentiment Degradation: Stakeholder trust is tied directly to communication transparency rather than just budget spend</a:t>
-            </a:r>
-          </a:p>
+              <a:t>• Communication Gap: Low sentiment in troubled projects correlates directly with lack of visibility into blockers</a:t>
+            </a:r>
+          </a:p>
+        </p:txBody>
+      </p:sp>
+      <p:sp>
+        <p:nvSpPr>
+          <p:cNvPr id="4" name="TextBox 3"/>
+          <p:cNvSpPr txBox="1"/>
+          <p:nvPr/>
+        </p:nvSpPr>
+        <p:spPr>
+          <a:xfrm>
+            <a:off x="4754880" y="1371600"/>
+            <a:ext cx="3931920" cy="4572000"/>
+          </a:xfrm>
+          <a:prstGeom prst="rect">
+            <a:avLst/>
+          </a:prstGeom>
+          <a:noFill/>
+        </p:spPr>
+        <p:txBody>
+          <a:bodyPr wrap="square">
+            <a:spAutoFit/>
+          </a:bodyPr>
+          <a:lstStyle/>
           <a:p>
             <a:pPr>
               <a:spcAft>
-                <a:spcPts val="1400"/>
+                <a:spcPts val="1000"/>
               </a:spcAft>
-              <a:defRPr sz="1600">
+              <a:defRPr sz="1400">
                 <a:solidFill>
                   <a:srgbClr val="212529"/>
                 </a:solidFill>
               </a:defRPr>
             </a:pPr>
             <a:r>
-              <a:t>• Efficiency Gap: A 33% variance in task completion rates suggests inconsistent execution standards across project teams</a:t>
+              <a:t>• High Velocity vs. Execution Drag: Alpha shows 96% task completion, while Gamma suffers from a 33% task deficit</a:t>
+            </a:r>
+          </a:p>
+          <a:p>
+            <a:pPr>
+              <a:spcAft>
+                <a:spcPts val="1000"/>
+              </a:spcAft>
+              <a:defRPr sz="1400">
+                <a:solidFill>
+                  <a:srgbClr val="212529"/>
+                </a:solidFill>
+              </a:defRPr>
+            </a:pPr>
+            <a:r>
+              <a:t>• Trend Analysis: Projects exceeding 100 days (Beta) are showing heightened sensitivity to external dependencies</a:t>
             </a:r>
           </a:p>
         </p:txBody>
@@ -3518,7 +3556,7 @@
         <p:spPr>
           <a:xfrm>
             <a:off x="457200" y="1371600"/>
-            <a:ext cx="3931920" cy="4572000"/>
+            <a:ext cx="8229600" cy="4572000"/>
           </a:xfrm>
           <a:prstGeom prst="rect">
             <a:avLst/>
@@ -3533,99 +3571,61 @@
           <a:p>
             <a:pPr>
               <a:spcAft>
-                <a:spcPts val="1000"/>
+                <a:spcPts val="1400"/>
               </a:spcAft>
-              <a:defRPr sz="1400">
+              <a:defRPr sz="1600">
                 <a:solidFill>
                   <a:srgbClr val="212529"/>
                 </a:solidFill>
               </a:defRPr>
             </a:pPr>
             <a:r>
-              <a:t>• External Dependencies: API integration delays (Beta) creating critical path bottlenecks</a:t>
+              <a:t>• External Dependency Chain: API integration delays (Beta) are creating cascading timeline risks</a:t>
             </a:r>
           </a:p>
           <a:p>
             <a:pPr>
               <a:spcAft>
-                <a:spcPts val="1000"/>
+                <a:spcPts val="1400"/>
               </a:spcAft>
-              <a:defRPr sz="1400">
+              <a:defRPr sz="1600">
                 <a:solidFill>
                   <a:srgbClr val="212529"/>
                 </a:solidFill>
               </a:defRPr>
             </a:pPr>
             <a:r>
-              <a:t>• Resource Availability: Persistent unavailability of client resources stalling progress in Gamma</a:t>
+              <a:t>• Client Resource Constraint: High-severity resource unavailability (Gamma) is a primary blocker for critical path movement</a:t>
             </a:r>
           </a:p>
           <a:p>
             <a:pPr>
               <a:spcAft>
-                <a:spcPts val="1000"/>
+                <a:spcPts val="1400"/>
               </a:spcAft>
-              <a:defRPr sz="1400">
+              <a:defRPr sz="1600">
                 <a:solidFill>
                   <a:srgbClr val="212529"/>
                 </a:solidFill>
               </a:defRPr>
             </a:pPr>
             <a:r>
-              <a:t>• Scope Management: Uncontrolled scope creep within Module B (Gamma) exacerbating budget overruns</a:t>
-            </a:r>
-          </a:p>
-        </p:txBody>
-      </p:sp>
-      <p:sp>
-        <p:nvSpPr>
-          <p:cNvPr id="4" name="TextBox 3"/>
-          <p:cNvSpPr txBox="1"/>
-          <p:nvPr/>
-        </p:nvSpPr>
-        <p:spPr>
-          <a:xfrm>
-            <a:off x="4754880" y="1371600"/>
-            <a:ext cx="3931920" cy="4572000"/>
-          </a:xfrm>
-          <a:prstGeom prst="rect">
-            <a:avLst/>
-          </a:prstGeom>
-          <a:noFill/>
-        </p:spPr>
-        <p:txBody>
-          <a:bodyPr wrap="square">
-            <a:spAutoFit/>
-          </a:bodyPr>
-          <a:lstStyle/>
+              <a:t>• Scope Instability: Uncontrolled scope creep in module-level development is destabilizing project baselines</a:t>
+            </a:r>
+          </a:p>
           <a:p>
             <a:pPr>
               <a:spcAft>
-                <a:spcPts val="1000"/>
+                <a:spcPts val="1400"/>
               </a:spcAft>
-              <a:defRPr sz="1400">
+              <a:defRPr sz="1600">
                 <a:solidFill>
                   <a:srgbClr val="212529"/>
                 </a:solidFill>
               </a:defRPr>
             </a:pPr>
             <a:r>
-              <a:t>• Vendor Management: Current vendor performance is a primary driver of stakeholder frustration in Beta</a:t>
-            </a:r>
-          </a:p>
-          <a:p>
-            <a:pPr>
-              <a:spcAft>
-                <a:spcPts val="1000"/>
-              </a:spcAft>
-              <a:defRPr sz="1400">
-                <a:solidFill>
-                  <a:srgbClr val="212529"/>
-                </a:solidFill>
-              </a:defRPr>
-            </a:pPr>
-            <a:r>
-              <a:t>• Communication Gaps: Lack of proactive reporting is transforming operational blockers into critical trust issues</a:t>
+              <a:t>• Stakeholder Trust Erosion: Poor transparency in troubled workstreams is threatening overall program sponsorship</a:t>
             </a:r>
           </a:p>
         </p:txBody>
@@ -3690,7 +3690,7 @@
               </a:defRPr>
             </a:pPr>
             <a:r>
-              <a:t>Reallocation and Efficiency Strategies</a:t>
+              <a:t>Reallocation and Efficiency Strategy</a:t>
             </a:r>
           </a:p>
         </p:txBody>
@@ -3704,7 +3704,7 @@
         <p:spPr>
           <a:xfrm>
             <a:off x="457200" y="1371600"/>
-            <a:ext cx="8229600" cy="4572000"/>
+            <a:ext cx="3931920" cy="4572000"/>
           </a:xfrm>
           <a:prstGeom prst="rect">
             <a:avLst/>
@@ -3719,61 +3719,84 @@
           <a:p>
             <a:pPr>
               <a:spcAft>
-                <a:spcPts val="1400"/>
+                <a:spcPts val="1000"/>
               </a:spcAft>
-              <a:defRPr sz="1600">
+              <a:defRPr sz="1400">
                 <a:solidFill>
                   <a:srgbClr val="212529"/>
                 </a:solidFill>
               </a:defRPr>
             </a:pPr>
             <a:r>
-              <a:t>• Fiscal Balancing: Leverage the $20k underspend from Project Alpha to support mitigation efforts in Red/Amber projects</a:t>
+              <a:t>• Surplus Reallocation: Alpha (nearing completion) resources are flagged for transition to support Beta/Gamma recovery</a:t>
             </a:r>
           </a:p>
           <a:p>
             <a:pPr>
               <a:spcAft>
-                <a:spcPts val="1400"/>
+                <a:spcPts val="1000"/>
               </a:spcAft>
-              <a:defRPr sz="1600">
+              <a:defRPr sz="1400">
                 <a:solidFill>
                   <a:srgbClr val="212529"/>
                 </a:solidFill>
               </a:defRPr>
             </a:pPr>
             <a:r>
-              <a:t>• Capacity Rebalancing: Audit team utilization on Beta/Gamma to ensure critical path tasks are prioritized over non-essential features</a:t>
-            </a:r>
-          </a:p>
+              <a:t>• Budget Utilization: Proactive management of the $150k vs $80k cost centers to protect portfolio contingency funds</a:t>
+            </a:r>
+          </a:p>
+        </p:txBody>
+      </p:sp>
+      <p:sp>
+        <p:nvSpPr>
+          <p:cNvPr id="4" name="TextBox 3"/>
+          <p:cNvSpPr txBox="1"/>
+          <p:nvPr/>
+        </p:nvSpPr>
+        <p:spPr>
+          <a:xfrm>
+            <a:off x="4754880" y="1371600"/>
+            <a:ext cx="3931920" cy="4572000"/>
+          </a:xfrm>
+          <a:prstGeom prst="rect">
+            <a:avLst/>
+          </a:prstGeom>
+          <a:noFill/>
+        </p:spPr>
+        <p:txBody>
+          <a:bodyPr wrap="square">
+            <a:spAutoFit/>
+          </a:bodyPr>
+          <a:lstStyle/>
           <a:p>
             <a:pPr>
               <a:spcAft>
-                <a:spcPts val="1400"/>
+                <a:spcPts val="1000"/>
               </a:spcAft>
-              <a:defRPr sz="1600">
+              <a:defRPr sz="1400">
                 <a:solidFill>
                   <a:srgbClr val="212529"/>
                 </a:solidFill>
               </a:defRPr>
             </a:pPr>
             <a:r>
-              <a:t>• Operational Transition: Initiate formal handovers for Project Alpha to free up project leadership bandwidth for recovery efforts</a:t>
+              <a:t>• Resource Balancing: Shift focus from task-heavy overhead to critical-path-only activity for red-status projects</a:t>
             </a:r>
           </a:p>
           <a:p>
             <a:pPr>
               <a:spcAft>
-                <a:spcPts val="1400"/>
+                <a:spcPts val="1000"/>
               </a:spcAft>
-              <a:defRPr sz="1600">
+              <a:defRPr sz="1400">
                 <a:solidFill>
                   <a:srgbClr val="212529"/>
                 </a:solidFill>
               </a:defRPr>
             </a:pPr>
             <a:r>
-              <a:t>• Vendor Accountability: Apply financial leverage from current vendor contracts to enforce delivery commitments for the API dependency</a:t>
+              <a:t>• Vendor Management: Renegotiate API delivery commitments for Beta to prevent further fiscal leakage</a:t>
             </a:r>
           </a:p>
         </p:txBody>
@@ -3838,7 +3861,7 @@
               </a:defRPr>
             </a:pPr>
             <a:r>
-              <a:t>Roadmap for Portfolio Stabilization</a:t>
+              <a:t>Roadmap to Recovery and Completion</a:t>
             </a:r>
           </a:p>
         </p:txBody>
@@ -3876,7 +3899,7 @@
               </a:defRPr>
             </a:pPr>
             <a:r>
-              <a:t>• Emergency Alignment: Conduct leadership-level syncs to reset scope and delivery expectations for Project Gamma</a:t>
+              <a:t>• Immediate: Implement a 'Scope Freeze' on Gamma and execute a formal recovery plan with stakeholders</a:t>
             </a:r>
           </a:p>
           <a:p>
@@ -3891,7 +3914,7 @@
               </a:defRPr>
             </a:pPr>
             <a:r>
-              <a:t>• Recovery Planning: Implement rigorous change control (Scope Freeze) for Gamma and finalize a re-baselined plan for Beta</a:t>
+              <a:t>• Operational: Establish a high-frequency (weekly) sync for project Beta to expedite vendor API resolution</a:t>
             </a:r>
           </a:p>
           <a:p>
@@ -3906,7 +3929,7 @@
               </a:defRPr>
             </a:pPr>
             <a:r>
-              <a:t>• Governance Enhancement: Standardize reporting cadence to improve stakeholder transparency and restore confidence</a:t>
+              <a:t>• Closure: Finalize transition artifacts and support handover for Project Alpha</a:t>
             </a:r>
           </a:p>
           <a:p>
@@ -3921,7 +3944,7 @@
               </a:defRPr>
             </a:pPr>
             <a:r>
-              <a:t>• Delivery Excellence: Formalize lessons learned from Project Alpha to replicate successful communication and execution models</a:t>
+              <a:t>• Governance: Standardize reporting cadence across the portfolio to restore stakeholder confidence</a:t>
             </a:r>
           </a:p>
         </p:txBody>

</xml_diff>